<commit_message>
Adds some sql statements
</commit_message>
<xml_diff>
--- a/slides/06-querying-llms.pptx
+++ b/slides/06-querying-llms.pptx
@@ -215,7 +215,7 @@
           <a:p>
             <a:fld id="{15DA2908-672F-DC48-8CAD-AEE711B947DA}" type="datetimeFigureOut">
               <a:rPr lang="en-US" smtClean="0"/>
-              <a:t>6/29/25</a:t>
+              <a:t>7/28/26</a:t>
             </a:fld>
             <a:endParaRPr lang="en-US"/>
           </a:p>
@@ -911,6 +911,13 @@
               </a:ext>
             </a:extLst>
           </p:spPr>
+          <p:txBody>
+            <a:bodyPr/>
+            <a:lstStyle/>
+            <a:p>
+              <a:endParaRPr lang="en-US"/>
+            </a:p>
+          </p:txBody>
         </p:sp>
         <p:sp>
           <p:nvSpPr>
@@ -979,6 +986,13 @@
               </a:ext>
             </a:extLst>
           </p:spPr>
+          <p:txBody>
+            <a:bodyPr/>
+            <a:lstStyle/>
+            <a:p>
+              <a:endParaRPr lang="en-US"/>
+            </a:p>
+          </p:txBody>
         </p:sp>
         <p:sp>
           <p:nvSpPr>
@@ -1052,6 +1066,13 @@
               </a:ext>
             </a:extLst>
           </p:spPr>
+          <p:txBody>
+            <a:bodyPr/>
+            <a:lstStyle/>
+            <a:p>
+              <a:endParaRPr lang="en-US"/>
+            </a:p>
+          </p:txBody>
         </p:sp>
         <p:sp>
           <p:nvSpPr>
@@ -1115,6 +1136,13 @@
               </a:ext>
             </a:extLst>
           </p:spPr>
+          <p:txBody>
+            <a:bodyPr/>
+            <a:lstStyle/>
+            <a:p>
+              <a:endParaRPr lang="en-US"/>
+            </a:p>
+          </p:txBody>
         </p:sp>
         <p:sp>
           <p:nvSpPr>
@@ -1168,6 +1196,13 @@
               </a:ext>
             </a:extLst>
           </p:spPr>
+          <p:txBody>
+            <a:bodyPr/>
+            <a:lstStyle/>
+            <a:p>
+              <a:endParaRPr lang="en-US"/>
+            </a:p>
+          </p:txBody>
         </p:sp>
         <p:sp>
           <p:nvSpPr>
@@ -1231,6 +1266,13 @@
               </a:ext>
             </a:extLst>
           </p:spPr>
+          <p:txBody>
+            <a:bodyPr/>
+            <a:lstStyle/>
+            <a:p>
+              <a:endParaRPr lang="en-US"/>
+            </a:p>
+          </p:txBody>
         </p:sp>
         <p:sp>
           <p:nvSpPr>
@@ -1289,6 +1331,13 @@
               </a:ext>
             </a:extLst>
           </p:spPr>
+          <p:txBody>
+            <a:bodyPr/>
+            <a:lstStyle/>
+            <a:p>
+              <a:endParaRPr lang="en-US"/>
+            </a:p>
+          </p:txBody>
         </p:sp>
         <p:sp>
           <p:nvSpPr>
@@ -1342,6 +1391,13 @@
               </a:ext>
             </a:extLst>
           </p:spPr>
+          <p:txBody>
+            <a:bodyPr/>
+            <a:lstStyle/>
+            <a:p>
+              <a:endParaRPr lang="en-US"/>
+            </a:p>
+          </p:txBody>
         </p:sp>
         <p:sp>
           <p:nvSpPr>
@@ -1400,6 +1456,13 @@
               </a:ext>
             </a:extLst>
           </p:spPr>
+          <p:txBody>
+            <a:bodyPr/>
+            <a:lstStyle/>
+            <a:p>
+              <a:endParaRPr lang="en-US"/>
+            </a:p>
+          </p:txBody>
         </p:sp>
         <p:sp>
           <p:nvSpPr>
@@ -1453,6 +1516,13 @@
               </a:ext>
             </a:extLst>
           </p:spPr>
+          <p:txBody>
+            <a:bodyPr/>
+            <a:lstStyle/>
+            <a:p>
+              <a:endParaRPr lang="en-US"/>
+            </a:p>
+          </p:txBody>
         </p:sp>
         <p:sp>
           <p:nvSpPr>
@@ -1511,6 +1581,13 @@
               </a:ext>
             </a:extLst>
           </p:spPr>
+          <p:txBody>
+            <a:bodyPr/>
+            <a:lstStyle/>
+            <a:p>
+              <a:endParaRPr lang="en-US"/>
+            </a:p>
+          </p:txBody>
         </p:sp>
         <p:sp>
           <p:nvSpPr>
@@ -1564,6 +1641,13 @@
               </a:ext>
             </a:extLst>
           </p:spPr>
+          <p:txBody>
+            <a:bodyPr/>
+            <a:lstStyle/>
+            <a:p>
+              <a:endParaRPr lang="en-US"/>
+            </a:p>
+          </p:txBody>
         </p:sp>
         <p:sp>
           <p:nvSpPr>
@@ -1622,6 +1706,13 @@
               </a:ext>
             </a:extLst>
           </p:spPr>
+          <p:txBody>
+            <a:bodyPr/>
+            <a:lstStyle/>
+            <a:p>
+              <a:endParaRPr lang="en-US"/>
+            </a:p>
+          </p:txBody>
         </p:sp>
         <p:sp>
           <p:nvSpPr>
@@ -1680,6 +1771,13 @@
               </a:ext>
             </a:extLst>
           </p:spPr>
+          <p:txBody>
+            <a:bodyPr/>
+            <a:lstStyle/>
+            <a:p>
+              <a:endParaRPr lang="en-US"/>
+            </a:p>
+          </p:txBody>
         </p:sp>
         <p:sp>
           <p:nvSpPr>
@@ -1738,6 +1836,13 @@
               </a:ext>
             </a:extLst>
           </p:spPr>
+          <p:txBody>
+            <a:bodyPr/>
+            <a:lstStyle/>
+            <a:p>
+              <a:endParaRPr lang="en-US"/>
+            </a:p>
+          </p:txBody>
         </p:sp>
         <p:sp>
           <p:nvSpPr>
@@ -1791,6 +1896,13 @@
               </a:ext>
             </a:extLst>
           </p:spPr>
+          <p:txBody>
+            <a:bodyPr/>
+            <a:lstStyle/>
+            <a:p>
+              <a:endParaRPr lang="en-US"/>
+            </a:p>
+          </p:txBody>
         </p:sp>
         <p:sp>
           <p:nvSpPr>
@@ -1844,6 +1956,13 @@
               </a:ext>
             </a:extLst>
           </p:spPr>
+          <p:txBody>
+            <a:bodyPr/>
+            <a:lstStyle/>
+            <a:p>
+              <a:endParaRPr lang="en-US"/>
+            </a:p>
+          </p:txBody>
         </p:sp>
         <p:sp>
           <p:nvSpPr>
@@ -1897,6 +2016,13 @@
               </a:ext>
             </a:extLst>
           </p:spPr>
+          <p:txBody>
+            <a:bodyPr/>
+            <a:lstStyle/>
+            <a:p>
+              <a:endParaRPr lang="en-US"/>
+            </a:p>
+          </p:txBody>
         </p:sp>
         <p:sp>
           <p:nvSpPr>
@@ -1950,6 +2076,13 @@
               </a:ext>
             </a:extLst>
           </p:spPr>
+          <p:txBody>
+            <a:bodyPr/>
+            <a:lstStyle/>
+            <a:p>
+              <a:endParaRPr lang="en-US"/>
+            </a:p>
+          </p:txBody>
         </p:sp>
       </p:grpSp>
       <p:grpSp>
@@ -2003,6 +2136,13 @@
               <a:schemeClr val="lt1"/>
             </a:fontRef>
           </p:style>
+          <p:txBody>
+            <a:bodyPr/>
+            <a:lstStyle/>
+            <a:p>
+              <a:endParaRPr lang="en-US"/>
+            </a:p>
+          </p:txBody>
         </p:sp>
         <p:sp>
           <p:nvSpPr>
@@ -2041,6 +2181,13 @@
               <a:schemeClr val="lt1"/>
             </a:fontRef>
           </p:style>
+          <p:txBody>
+            <a:bodyPr/>
+            <a:lstStyle/>
+            <a:p>
+              <a:endParaRPr lang="en-US"/>
+            </a:p>
+          </p:txBody>
         </p:sp>
         <p:sp>
           <p:nvSpPr>
@@ -2079,6 +2226,13 @@
               <a:schemeClr val="lt1"/>
             </a:fontRef>
           </p:style>
+          <p:txBody>
+            <a:bodyPr/>
+            <a:lstStyle/>
+            <a:p>
+              <a:endParaRPr lang="en-US"/>
+            </a:p>
+          </p:txBody>
         </p:sp>
       </p:grpSp>
       <p:sp>
@@ -2222,7 +2376,7 @@
           <a:p>
             <a:fld id="{F6CCBF3A-D7FB-4B97-8FD5-6FFB20CB1E84}" type="datetimeFigureOut">
               <a:rPr lang="en-US" smtClean="0"/>
-              <a:t>6/29/25</a:t>
+              <a:t>7/28/26</a:t>
             </a:fld>
             <a:endParaRPr lang="en-US"/>
           </a:p>
@@ -3681,7 +3835,7 @@
           <a:p>
             <a:fld id="{F6CCBF3A-D7FB-4B97-8FD5-6FFB20CB1E84}" type="datetimeFigureOut">
               <a:rPr lang="en-US" smtClean="0"/>
-              <a:t>6/29/25</a:t>
+              <a:t>7/28/26</a:t>
             </a:fld>
             <a:endParaRPr lang="en-US"/>
           </a:p>
@@ -5134,7 +5288,7 @@
           <a:p>
             <a:fld id="{F6CCBF3A-D7FB-4B97-8FD5-6FFB20CB1E84}" type="datetimeFigureOut">
               <a:rPr lang="en-US" smtClean="0"/>
-              <a:t>6/29/25</a:t>
+              <a:t>7/28/26</a:t>
             </a:fld>
             <a:endParaRPr lang="en-US"/>
           </a:p>
@@ -8050,7 +8204,7 @@
           <a:p>
             <a:fld id="{F6CCBF3A-D7FB-4B97-8FD5-6FFB20CB1E84}" type="datetimeFigureOut">
               <a:rPr lang="en-US" smtClean="0"/>
-              <a:t>6/29/25</a:t>
+              <a:t>7/28/26</a:t>
             </a:fld>
             <a:endParaRPr lang="en-US"/>
           </a:p>
@@ -10294,7 +10448,7 @@
           <a:p>
             <a:fld id="{F6CCBF3A-D7FB-4B97-8FD5-6FFB20CB1E84}" type="datetimeFigureOut">
               <a:rPr lang="en-US" smtClean="0"/>
-              <a:t>6/29/25</a:t>
+              <a:t>7/28/26</a:t>
             </a:fld>
             <a:endParaRPr lang="en-US"/>
           </a:p>
@@ -11815,7 +11969,7 @@
           <a:p>
             <a:fld id="{F6CCBF3A-D7FB-4B97-8FD5-6FFB20CB1E84}" type="datetimeFigureOut">
               <a:rPr lang="en-US" smtClean="0"/>
-              <a:t>6/29/25</a:t>
+              <a:t>7/28/26</a:t>
             </a:fld>
             <a:endParaRPr lang="en-US"/>
           </a:p>
@@ -13480,7 +13634,7 @@
           <a:p>
             <a:fld id="{F6CCBF3A-D7FB-4B97-8FD5-6FFB20CB1E84}" type="datetimeFigureOut">
               <a:rPr lang="en-US" smtClean="0"/>
-              <a:t>6/29/25</a:t>
+              <a:t>7/28/26</a:t>
             </a:fld>
             <a:endParaRPr lang="en-US"/>
           </a:p>
@@ -14878,7 +15032,7 @@
           <a:p>
             <a:fld id="{F6CCBF3A-D7FB-4B97-8FD5-6FFB20CB1E84}" type="datetimeFigureOut">
               <a:rPr lang="en-US" smtClean="0"/>
-              <a:t>6/29/25</a:t>
+              <a:t>7/28/26</a:t>
             </a:fld>
             <a:endParaRPr lang="en-US"/>
           </a:p>
@@ -14978,7 +15132,7 @@
           <a:p>
             <a:fld id="{F6CCBF3A-D7FB-4B97-8FD5-6FFB20CB1E84}" type="datetimeFigureOut">
               <a:rPr lang="en-US" smtClean="0"/>
-              <a:t>6/29/25</a:t>
+              <a:t>7/28/26</a:t>
             </a:fld>
             <a:endParaRPr lang="en-US"/>
           </a:p>
@@ -16504,7 +16658,7 @@
           <a:p>
             <a:fld id="{F6CCBF3A-D7FB-4B97-8FD5-6FFB20CB1E84}" type="datetimeFigureOut">
               <a:rPr lang="en-US" smtClean="0"/>
-              <a:t>6/29/25</a:t>
+              <a:t>7/28/26</a:t>
             </a:fld>
             <a:endParaRPr lang="en-US"/>
           </a:p>
@@ -18040,7 +18194,7 @@
           <a:p>
             <a:fld id="{F6CCBF3A-D7FB-4B97-8FD5-6FFB20CB1E84}" type="datetimeFigureOut">
               <a:rPr lang="en-US" smtClean="0"/>
-              <a:t>6/29/25</a:t>
+              <a:t>7/28/26</a:t>
             </a:fld>
             <a:endParaRPr lang="en-US"/>
           </a:p>
@@ -18263,7 +18417,7 @@
           <a:p>
             <a:fld id="{F6CCBF3A-D7FB-4B97-8FD5-6FFB20CB1E84}" type="datetimeFigureOut">
               <a:rPr lang="en-US" smtClean="0"/>
-              <a:t>6/29/25</a:t>
+              <a:t>7/28/26</a:t>
             </a:fld>
             <a:endParaRPr lang="en-US"/>
           </a:p>

</xml_diff>